<commit_message>
feat: add voice assistant protocol, 1rm overload engine, muscular anatomy heatmap, and circadian readiness protocol
</commit_message>
<xml_diff>
--- a/IronPulse_Innovesta_2026.pptx
+++ b/IronPulse_Innovesta_2026.pptx
@@ -5206,7 +5206,7 @@
               </a:defRPr>
             </a:pPr>
             <a:r>
-              <a:t>⏱️ Picture-in-Picture Floating HUD</a:t>
+              <a:t>🎙️ Hands-Free Voice Protocol (Hotkey: V)</a:t>
             </a:r>
           </a:p>
         </p:txBody>
@@ -5242,11 +5242,11 @@
               </a:defRPr>
             </a:pPr>
             <a:r>
-              <a:t>When rest timer starts, navigating to Workouts or Calendar docks a floating mini-player.</a:t>
+              <a:t>Zero-touch in-gym voice assistant using Web Speech API &amp; SpeechSynthesis.</a:t>
             </a:r>
             <a:br/>
             <a:r>
-              <a:t>Displays live countdown, +30s boost, pause/reset, and Web Audio melodic chimes on completion.</a:t>
+              <a:t>Supports natural voice commands: timer, check-in, 1RM calculator, navigation &amp; audio feedback.</a:t>
             </a:r>
           </a:p>
         </p:txBody>
@@ -5327,7 +5327,7 @@
               </a:defRPr>
             </a:pPr>
             <a:r>
-              <a:t>⚡ 1-Tap Quick Action Speed-Dial (FAB)</a:t>
+              <a:t>⏱️ Picture-in-Picture Floating HUD</a:t>
             </a:r>
           </a:p>
         </p:txBody>
@@ -5363,11 +5363,11 @@
               </a:defRPr>
             </a:pPr>
             <a:r>
-              <a:t>Floating action button pinned at bottom-right for thumb reach.</a:t>
+              <a:t>When rest timer starts, navigating to other views docks a floating mini-player.</a:t>
             </a:r>
             <a:br/>
             <a:r>
-              <a:t>Opens 1-tap shortcuts: Log Workout, Check In Today, Start 90s Rest, or Add Expense without scrolling.</a:t>
+              <a:t>Displays live countdown, +30s boost, pause/reset, and Web Audio melodic chimes on completion.</a:t>
             </a:r>
           </a:p>
         </p:txBody>
@@ -5448,7 +5448,7 @@
               </a:defRPr>
             </a:pPr>
             <a:r>
-              <a:t>📲 Haptic &amp; Sound Feedback Engine</a:t>
+              <a:t>⚡ 1-Tap Quick Action Speed-Dial (FAB)</a:t>
             </a:r>
           </a:p>
         </p:txBody>
@@ -5484,11 +5484,11 @@
               </a:defRPr>
             </a:pPr>
             <a:r>
-              <a:t>Web Audio API synthesized frequencies (523Hz - 783Hz melodic chime) with zero audio assets.</a:t>
+              <a:t>Floating action button pinned at bottom-right for instant one-thumb reach.</a:t>
             </a:r>
             <a:br/>
             <a:r>
-              <a:t>Vibration API multi-pattern tactile feedback on set completion and check-ins.</a:t>
+              <a:t>Opens 1-tap shortcuts: Log Workout, Voice Assistant, 1RM Engine, 90s Rest, or Check-In.</a:t>
             </a:r>
           </a:p>
         </p:txBody>
@@ -6507,7 +6507,7 @@
               </a:defRPr>
             </a:pPr>
             <a:r>
-              <a:t>ATELIER AESTHETIC</a:t>
+              <a:t>BIOMECHANICAL INTELLIGENCE</a:t>
             </a:r>
           </a:p>
         </p:txBody>
@@ -6543,7 +6543,7 @@
               </a:defRPr>
             </a:pPr>
             <a:r>
-              <a:t>Visual Identity &amp; Sensory Micro-Interactions</a:t>
+              <a:t>Algorithmic Precision &amp; Haute Aesthetic</a:t>
             </a:r>
           </a:p>
         </p:txBody>
@@ -6593,7 +6593,7 @@
         <p:spPr>
           <a:xfrm>
             <a:off x="731520" y="1554480"/>
-            <a:ext cx="10728655" cy="1371600"/>
+            <a:ext cx="5212080" cy="2194560"/>
           </a:xfrm>
           <a:prstGeom prst="roundRect">
             <a:avLst/>
@@ -6638,7 +6638,7 @@
         <p:spPr>
           <a:xfrm>
             <a:off x="914400" y="1691640"/>
-            <a:ext cx="10362895" cy="457200"/>
+            <a:ext cx="4846320" cy="457200"/>
           </a:xfrm>
           <a:prstGeom prst="rect">
             <a:avLst/>
@@ -6660,7 +6660,7 @@
               </a:defRPr>
             </a:pPr>
             <a:r>
-              <a:t>🎨 Champagne Gold &amp; Midnight Caviar</a:t>
+              <a:t>🗺️ Muscular Anatomy Heatmap</a:t>
             </a:r>
           </a:p>
         </p:txBody>
@@ -6673,8 +6673,8 @@
         </p:nvSpPr>
         <p:spPr>
           <a:xfrm>
-            <a:off x="960120" y="2057400"/>
-            <a:ext cx="10241280" cy="777240"/>
+            <a:off x="960120" y="2286000"/>
+            <a:ext cx="4754880" cy="1371600"/>
           </a:xfrm>
           <a:prstGeom prst="rect">
             <a:avLst/>
@@ -6688,6 +6688,9 @@
           <a:lstStyle/>
           <a:p>
             <a:pPr>
+              <a:spcAft>
+                <a:spcPts val="400"/>
+              </a:spcAft>
               <a:defRPr sz="1200">
                 <a:solidFill>
                   <a:srgbClr val="F8F7F4"/>
@@ -6696,46 +6699,23 @@
               </a:defRPr>
             </a:pPr>
             <a:r>
-              <a:t>A bespoke aesthetic replacing boring fitness UI with luxury tones:</a:t>
-            </a:r>
-          </a:p>
-          <a:p>
-            <a:pPr>
+              <a:t>SVG anatomical front/back visualizer scanning 7-day cumulative set volume.</a:t>
+            </a:r>
+          </a:p>
+          <a:p>
+            <a:pPr>
+              <a:spcAft>
+                <a:spcPts val="400"/>
+              </a:spcAft>
               <a:defRPr sz="1200">
                 <a:solidFill>
-                  <a:srgbClr val="A5A096"/>
+                  <a:srgbClr val="F8F7F4"/>
                 </a:solidFill>
                 <a:latin typeface="Trebuchet MS"/>
               </a:defRPr>
             </a:pPr>
             <a:r>
-              <a:t>• Polished Gold (#DAB978) metallic gradients</a:t>
-            </a:r>
-          </a:p>
-          <a:p>
-            <a:pPr>
-              <a:defRPr sz="1200">
-                <a:solidFill>
-                  <a:srgbClr val="A5A096"/>
-                </a:solidFill>
-                <a:latin typeface="Trebuchet MS"/>
-              </a:defRPr>
-            </a:pPr>
-            <a:r>
-              <a:t>• Midnight Caviar (#08080A) OLED-friendly dark background</a:t>
-            </a:r>
-          </a:p>
-          <a:p>
-            <a:pPr>
-              <a:defRPr sz="1200">
-                <a:solidFill>
-                  <a:srgbClr val="A5A096"/>
-                </a:solidFill>
-                <a:latin typeface="Trebuchet MS"/>
-              </a:defRPr>
-            </a:pPr>
-            <a:r>
-              <a:t>• High legibility contrast ratios meeting WCAG AAA guidelines.</a:t>
+              <a:t>Dynamically maps 8 muscle groups across Cold, Active, Balanced, Optimal Gold, and CNS Fatigue.</a:t>
             </a:r>
           </a:p>
         </p:txBody>
@@ -6748,8 +6728,8 @@
         </p:nvSpPr>
         <p:spPr>
           <a:xfrm>
-            <a:off x="731520" y="3108960"/>
-            <a:ext cx="10728655" cy="1371600"/>
+            <a:off x="6217920" y="1554480"/>
+            <a:ext cx="5212080" cy="2194560"/>
           </a:xfrm>
           <a:prstGeom prst="roundRect">
             <a:avLst/>
@@ -6793,8 +6773,8 @@
         </p:nvSpPr>
         <p:spPr>
           <a:xfrm>
-            <a:off x="914400" y="3246120"/>
-            <a:ext cx="10362895" cy="457200"/>
+            <a:off x="6400800" y="1691640"/>
+            <a:ext cx="4846320" cy="457200"/>
           </a:xfrm>
           <a:prstGeom prst="rect">
             <a:avLst/>
@@ -6816,7 +6796,7 @@
               </a:defRPr>
             </a:pPr>
             <a:r>
-              <a:t>✨ Hardware-Accelerated Particle Canvas</a:t>
+              <a:t>🧬 1RM &amp; Progressive Overload Engine</a:t>
             </a:r>
           </a:p>
         </p:txBody>
@@ -6829,8 +6809,8 @@
         </p:nvSpPr>
         <p:spPr>
           <a:xfrm>
-            <a:off x="960120" y="3611880"/>
-            <a:ext cx="10241280" cy="777240"/>
+            <a:off x="6446520" y="2286000"/>
+            <a:ext cx="4754880" cy="1371600"/>
           </a:xfrm>
           <a:prstGeom prst="rect">
             <a:avLst/>
@@ -6844,6 +6824,9 @@
           <a:lstStyle/>
           <a:p>
             <a:pPr>
+              <a:spcAft>
+                <a:spcPts val="400"/>
+              </a:spcAft>
               <a:defRPr sz="1200">
                 <a:solidFill>
                   <a:srgbClr val="F8F7F4"/>
@@ -6852,46 +6835,23 @@
               </a:defRPr>
             </a:pPr>
             <a:r>
-              <a:t>Custom-coded HTML5 Canvas 60 FPS celebration engine:</a:t>
-            </a:r>
-          </a:p>
-          <a:p>
-            <a:pPr>
+              <a:t>Multi-equation consensus (Epley, Brzycki &amp; Lombardi models).</a:t>
+            </a:r>
+          </a:p>
+          <a:p>
+            <a:pPr>
+              <a:spcAft>
+                <a:spcPts val="400"/>
+              </a:spcAft>
               <a:defRPr sz="1200">
                 <a:solidFill>
-                  <a:srgbClr val="A5A096"/>
+                  <a:srgbClr val="F8F7F4"/>
                 </a:solidFill>
                 <a:latin typeface="Trebuchet MS"/>
               </a:defRPr>
             </a:pPr>
             <a:r>
-              <a:t>• 55+ physics-simulated champagne particles and diamond sparkles</a:t>
-            </a:r>
-          </a:p>
-          <a:p>
-            <a:pPr>
-              <a:defRPr sz="1200">
-                <a:solidFill>
-                  <a:srgbClr val="A5A096"/>
-                </a:solidFill>
-                <a:latin typeface="Trebuchet MS"/>
-              </a:defRPr>
-            </a:pPr>
-            <a:r>
-              <a:t>• Triggers dynamically on attendance check-in &amp; completed workout sets</a:t>
-            </a:r>
-          </a:p>
-          <a:p>
-            <a:pPr>
-              <a:defRPr sz="1200">
-                <a:solidFill>
-                  <a:srgbClr val="A5A096"/>
-                </a:solidFill>
-                <a:latin typeface="Trebuchet MS"/>
-              </a:defRPr>
-            </a:pPr>
-            <a:r>
-              <a:t>• Zero third-party dependencies or animation bloat.</a:t>
+              <a:t>Calculates true 1RM, 50%-95% working zones, and automated +2.5kg/+5kg next-session overload.</a:t>
             </a:r>
           </a:p>
         </p:txBody>
@@ -6904,8 +6864,8 @@
         </p:nvSpPr>
         <p:spPr>
           <a:xfrm>
-            <a:off x="731520" y="4663440"/>
-            <a:ext cx="10728655" cy="1371600"/>
+            <a:off x="731520" y="4023360"/>
+            <a:ext cx="5212080" cy="2194560"/>
           </a:xfrm>
           <a:prstGeom prst="roundRect">
             <a:avLst/>
@@ -6949,8 +6909,8 @@
         </p:nvSpPr>
         <p:spPr>
           <a:xfrm>
-            <a:off x="914400" y="4800600"/>
-            <a:ext cx="10362895" cy="457200"/>
+            <a:off x="914400" y="4160520"/>
+            <a:ext cx="4846320" cy="457200"/>
           </a:xfrm>
           <a:prstGeom prst="rect">
             <a:avLst/>
@@ -6972,7 +6932,7 @@
               </a:defRPr>
             </a:pPr>
             <a:r>
-              <a:t>🌊 Fluid Silk Page Transitions &amp; Glow</a:t>
+              <a:t>⚡ Athletic Readiness &amp; Circadian Protocol</a:t>
             </a:r>
           </a:p>
         </p:txBody>
@@ -6985,8 +6945,8 @@
         </p:nvSpPr>
         <p:spPr>
           <a:xfrm>
-            <a:off x="960120" y="5166360"/>
-            <a:ext cx="10241280" cy="777240"/>
+            <a:off x="960120" y="4754880"/>
+            <a:ext cx="4754880" cy="1371600"/>
           </a:xfrm>
           <a:prstGeom prst="rect">
             <a:avLst/>
@@ -7000,6 +6960,9 @@
           <a:lstStyle/>
           <a:p>
             <a:pPr>
+              <a:spcAft>
+                <a:spcPts val="400"/>
+              </a:spcAft>
               <a:defRPr sz="1200">
                 <a:solidFill>
                   <a:srgbClr val="F8F7F4"/>
@@ -7008,46 +6971,159 @@
               </a:defRPr>
             </a:pPr>
             <a:r>
-              <a:t>Every tab transition is treated as an intentional animation:</a:t>
-            </a:r>
-          </a:p>
-          <a:p>
-            <a:pPr>
+              <a:t>Daily composite biometric index (Sleep, Muscle Freshness, CNS Energy).</a:t>
+            </a:r>
+          </a:p>
+          <a:p>
+            <a:pPr>
+              <a:spcAft>
+                <a:spcPts val="400"/>
+              </a:spcAft>
               <a:defRPr sz="1200">
                 <a:solidFill>
-                  <a:srgbClr val="A5A096"/>
+                  <a:srgbClr val="F8F7F4"/>
                 </a:solidFill>
                 <a:latin typeface="Trebuchet MS"/>
               </a:defRPr>
             </a:pPr>
             <a:r>
-              <a:t>• Cubic-bezier slide-up and fade-in (380ms)</a:t>
-            </a:r>
-          </a:p>
-          <a:p>
-            <a:pPr>
+              <a:t>6-phase daily timeline covering hydration, pre-workout fuel, training windows, and recovery.</a:t>
+            </a:r>
+          </a:p>
+        </p:txBody>
+      </p:sp>
+      <p:sp>
+        <p:nvSpPr>
+          <p:cNvPr id="15" name="Rounded Rectangle 14"/>
+          <p:cNvSpPr/>
+          <p:nvPr/>
+        </p:nvSpPr>
+        <p:spPr>
+          <a:xfrm>
+            <a:off x="6217920" y="4023360"/>
+            <a:ext cx="5212080" cy="2194560"/>
+          </a:xfrm>
+          <a:prstGeom prst="roundRect">
+            <a:avLst/>
+          </a:prstGeom>
+          <a:solidFill>
+            <a:srgbClr val="16161E"/>
+          </a:solidFill>
+          <a:ln w="12700">
+            <a:solidFill>
+              <a:srgbClr val="2D2D3C"/>
+            </a:solidFill>
+          </a:ln>
+        </p:spPr>
+        <p:style>
+          <a:lnRef idx="1">
+            <a:schemeClr val="accent1"/>
+          </a:lnRef>
+          <a:fillRef idx="3">
+            <a:schemeClr val="accent1"/>
+          </a:fillRef>
+          <a:effectRef idx="2">
+            <a:schemeClr val="accent1"/>
+          </a:effectRef>
+          <a:fontRef idx="minor">
+            <a:schemeClr val="lt1"/>
+          </a:fontRef>
+        </p:style>
+        <p:txBody>
+          <a:bodyPr rtlCol="0" anchor="ctr"/>
+          <a:lstStyle/>
+          <a:p>
+            <a:pPr algn="ctr"/>
+          </a:p>
+        </p:txBody>
+      </p:sp>
+      <p:sp>
+        <p:nvSpPr>
+          <p:cNvPr id="16" name="TextBox 15"/>
+          <p:cNvSpPr txBox="1"/>
+          <p:nvPr/>
+        </p:nvSpPr>
+        <p:spPr>
+          <a:xfrm>
+            <a:off x="6400800" y="4160520"/>
+            <a:ext cx="4846320" cy="457200"/>
+          </a:xfrm>
+          <a:prstGeom prst="rect">
+            <a:avLst/>
+          </a:prstGeom>
+          <a:noFill/>
+        </p:spPr>
+        <p:txBody>
+          <a:bodyPr wrap="none">
+            <a:spAutoFit/>
+          </a:bodyPr>
+          <a:lstStyle/>
+          <a:p>
+            <a:pPr>
+              <a:defRPr sz="1500" b="1">
+                <a:solidFill>
+                  <a:srgbClr val="DAB978"/>
+                </a:solidFill>
+                <a:latin typeface="Georgia"/>
+              </a:defRPr>
+            </a:pPr>
+            <a:r>
+              <a:t>✨ 60 FPS Particle Canvas &amp; Atelier Palette</a:t>
+            </a:r>
+          </a:p>
+        </p:txBody>
+      </p:sp>
+      <p:sp>
+        <p:nvSpPr>
+          <p:cNvPr id="17" name="TextBox 16"/>
+          <p:cNvSpPr txBox="1"/>
+          <p:nvPr/>
+        </p:nvSpPr>
+        <p:spPr>
+          <a:xfrm>
+            <a:off x="6446520" y="4754880"/>
+            <a:ext cx="4754880" cy="1371600"/>
+          </a:xfrm>
+          <a:prstGeom prst="rect">
+            <a:avLst/>
+          </a:prstGeom>
+          <a:noFill/>
+        </p:spPr>
+        <p:txBody>
+          <a:bodyPr wrap="square">
+            <a:spAutoFit/>
+          </a:bodyPr>
+          <a:lstStyle/>
+          <a:p>
+            <a:pPr>
+              <a:spcAft>
+                <a:spcPts val="400"/>
+              </a:spcAft>
               <a:defRPr sz="1200">
                 <a:solidFill>
-                  <a:srgbClr val="A5A096"/>
+                  <a:srgbClr val="F8F7F4"/>
                 </a:solidFill>
                 <a:latin typeface="Trebuchet MS"/>
               </a:defRPr>
             </a:pPr>
             <a:r>
-              <a:t>• Ambient breathing golden aura in dark mode background</a:t>
-            </a:r>
-          </a:p>
-          <a:p>
-            <a:pPr>
+              <a:t>Midnight Caviar (#08080A) and Champagne Gold (#DAB978) dark palette.</a:t>
+            </a:r>
+          </a:p>
+          <a:p>
+            <a:pPr>
+              <a:spcAft>
+                <a:spcPts val="400"/>
+              </a:spcAft>
               <a:defRPr sz="1200">
                 <a:solidFill>
-                  <a:srgbClr val="A5A096"/>
+                  <a:srgbClr val="F8F7F4"/>
                 </a:solidFill>
                 <a:latin typeface="Trebuchet MS"/>
               </a:defRPr>
             </a:pPr>
             <a:r>
-              <a:t>• Flickering streak flame and metallic diagonal light sweeps on buttons.</a:t>
+              <a:t>Hardware-accelerated 55+ particle confetti physics on attendance check-in and set PRs.</a:t>
             </a:r>
           </a:p>
         </p:txBody>
@@ -8198,7 +8274,7 @@
               </a:defRPr>
             </a:pPr>
             <a:r>
-              <a:t>✔ Complete Fitness Lifecycle: Sets, attendance streaks, timers &amp; budgets.</a:t>
+              <a:t>✔ Complete Fitness Lifecycle: Sets, attendance streaks, timers &amp; fitness budget.</a:t>
             </a:r>
           </a:p>
           <a:p>
@@ -8214,7 +8290,7 @@
               </a:defRPr>
             </a:pPr>
             <a:r>
-              <a:t>✔ Zero Framework Overhead: Supercharged vanilla architecture running at 60 FPS.</a:t>
+              <a:t>✔ Algorithmic Intelligence: 1RM multi-equation engine, SVG anatomy heatmap &amp; daily readiness.</a:t>
             </a:r>
           </a:p>
           <a:p>
@@ -8230,7 +8306,7 @@
               </a:defRPr>
             </a:pPr>
             <a:r>
-              <a:t>✔ Resilient Offline Sync: Works without network, syncs seamlessly to Cloud.</a:t>
+              <a:t>✔ Ergonomic &amp; Hands-Free UX: Voice Assistant Protocol (V), Spotlight Hub (⌘K) &amp; Floating HUD.</a:t>
             </a:r>
           </a:p>
           <a:p>
@@ -8246,7 +8322,7 @@
               </a:defRPr>
             </a:pPr>
             <a:r>
-              <a:t>✔ Open-Source &amp; Scalable: Built as a free community utility for student athletes.</a:t>
+              <a:t>✔ Zero Framework Overhead: Offline-first PWA caching with Firebase cloud sync &amp; 60 FPS particles.</a:t>
             </a:r>
           </a:p>
         </p:txBody>

</xml_diff>